<commit_message>
W7 - Weekly report W07; Gantt tasks in verb and noun form with design due in week 12, backend slides updated after the merge, status-code legend and corrected survey limits
</commit_message>
<xml_diff>
--- a/weekly-reports/W07/Weekly_Report_W07.pptx
+++ b/weekly-reports/W07/Weekly_Report_W07.pptx
@@ -5108,7 +5108,7 @@
                 </a:solidFill>
                 <a:latin typeface="Arial"/>
               </a:rPr>
-              <a:t>On her branch · not merged</a:t>
+              <a:t>Merged into main</a:t>
             </a:r>
           </a:p>
         </p:txBody>
@@ -6455,7 +6455,7 @@
                 </a:solidFill>
                 <a:latin typeface="Arial"/>
               </a:rPr>
-              <a:t>01  Technical progress  ·  refactor-backend by Veronika, 3 commits</a:t>
+              <a:t>01  Technical progress  ·  refactor-backend by Veronika, merged into main on 28 October</a:t>
             </a:r>
           </a:p>
         </p:txBody>
@@ -6987,7 +6987,7 @@
                 </a:solidFill>
                 <a:latin typeface="Arial"/>
               </a:rPr>
-              <a:t>tests pass merged with today's main; no conflicts</a:t>
+              <a:t>tests pass on main after the merge, with the AI tests</a:t>
             </a:r>
           </a:p>
         </p:txBody>
@@ -7022,7 +7022,7 @@
                 </a:solidFill>
                 <a:latin typeface="Arial"/>
               </a:rPr>
-              <a:t>Rerun by us on 28 October in a separate checkout of the branch</a:t>
+              <a:t>Rerun by us on the branch and again on main after the merge</a:t>
             </a:r>
           </a:p>
         </p:txBody>
@@ -7558,7 +7558,7 @@
                 </a:solidFill>
                 <a:latin typeface="Arial"/>
               </a:rPr>
-              <a:t>Backend: review findings before merge</a:t>
+              <a:t>Backend: review findings after the merge</a:t>
             </a:r>
           </a:p>
         </p:txBody>
@@ -7712,7 +7712,7 @@
         <p:spPr>
           <a:xfrm>
             <a:off x="990600" y="2235200"/>
-            <a:ext cx="3454400" cy="711200"/>
+            <a:ext cx="3454400" cy="635000"/>
           </a:xfrm>
           <a:prstGeom prst="rect">
             <a:avLst/>
@@ -7764,7 +7764,7 @@
         </p:nvSpPr>
         <p:spPr>
           <a:xfrm>
-            <a:off x="635000" y="2971800"/>
+            <a:off x="635000" y="2895600"/>
             <a:ext cx="317500" cy="368300"/>
           </a:xfrm>
           <a:prstGeom prst="rect">
@@ -7799,8 +7799,8 @@
         </p:nvSpPr>
         <p:spPr>
           <a:xfrm>
-            <a:off x="990600" y="2971800"/>
-            <a:ext cx="3454400" cy="711200"/>
+            <a:off x="990600" y="2895600"/>
+            <a:ext cx="3454400" cy="635000"/>
           </a:xfrm>
           <a:prstGeom prst="rect">
             <a:avLst/>
@@ -7852,7 +7852,7 @@
         </p:nvSpPr>
         <p:spPr>
           <a:xfrm>
-            <a:off x="635000" y="3708400"/>
+            <a:off x="635000" y="3556000"/>
             <a:ext cx="317500" cy="368300"/>
           </a:xfrm>
           <a:prstGeom prst="rect">
@@ -7887,8 +7887,8 @@
         </p:nvSpPr>
         <p:spPr>
           <a:xfrm>
-            <a:off x="990600" y="3708400"/>
-            <a:ext cx="3454400" cy="711200"/>
+            <a:off x="990600" y="3556000"/>
+            <a:ext cx="3454400" cy="635000"/>
           </a:xfrm>
           <a:prstGeom prst="rect">
             <a:avLst/>
@@ -7934,14 +7934,102 @@
       </p:sp>
       <p:sp>
         <p:nvSpPr>
-          <p:cNvPr id="12" name="Rectangle 11"/>
+          <p:cNvPr id="12" name="TextBox 11"/>
+          <p:cNvSpPr txBox="1"/>
+          <p:nvPr/>
+        </p:nvSpPr>
+        <p:spPr>
+          <a:xfrm>
+            <a:off x="635000" y="4216400"/>
+            <a:ext cx="317500" cy="368300"/>
+          </a:xfrm>
+          <a:prstGeom prst="rect">
+            <a:avLst/>
+          </a:prstGeom>
+          <a:noFill/>
+        </p:spPr>
+        <p:txBody>
+          <a:bodyPr wrap="square" lIns="45720" rIns="45720" tIns="12700" bIns="12700" anchor="t">
+            <a:spAutoFit/>
+          </a:bodyPr>
+          <a:lstStyle/>
+          <a:p>
+            <a:pPr algn="l"/>
+            <a:r>
+              <a:rPr sz="1650" b="1" i="0">
+                <a:solidFill>
+                  <a:srgbClr val="1F8A5B"/>
+                </a:solidFill>
+                <a:latin typeface="Arial"/>
+              </a:rPr>
+              <a:t>✓</a:t>
+            </a:r>
+          </a:p>
+        </p:txBody>
+      </p:sp>
+      <p:sp>
+        <p:nvSpPr>
+          <p:cNvPr id="13" name="TextBox 12"/>
+          <p:cNvSpPr txBox="1"/>
+          <p:nvPr/>
+        </p:nvSpPr>
+        <p:spPr>
+          <a:xfrm>
+            <a:off x="990600" y="4216400"/>
+            <a:ext cx="3454400" cy="635000"/>
+          </a:xfrm>
+          <a:prstGeom prst="rect">
+            <a:avLst/>
+          </a:prstGeom>
+          <a:noFill/>
+        </p:spPr>
+        <p:txBody>
+          <a:bodyPr wrap="square" lIns="45720" rIns="45720" tIns="12700" bIns="12700" anchor="t">
+            <a:spAutoFit/>
+          </a:bodyPr>
+          <a:lstStyle/>
+          <a:p>
+            <a:pPr algn="l"/>
+            <a:r>
+              <a:rPr sz="1500" b="1" i="0">
+                <a:solidFill>
+                  <a:srgbClr val="13263A"/>
+                </a:solidFill>
+                <a:latin typeface="Arial"/>
+              </a:rPr>
+              <a:t>DATABASE.md</a:t>
+            </a:r>
+            <a:r>
+              <a:rPr sz="1400" b="0" i="0">
+                <a:solidFill>
+                  <a:srgbClr val="13263A"/>
+                </a:solidFill>
+                <a:latin typeface="Arial"/>
+              </a:rPr>
+              <a:t>  </a:t>
+            </a:r>
+            <a:r>
+              <a:rPr sz="1350" b="0" i="0">
+                <a:solidFill>
+                  <a:srgbClr val="647080"/>
+                </a:solidFill>
+                <a:latin typeface="Arial"/>
+              </a:rPr>
+              <a:t>retrieval described as implemented</a:t>
+            </a:r>
+          </a:p>
+        </p:txBody>
+      </p:sp>
+      <p:sp>
+        <p:nvSpPr>
+          <p:cNvPr id="14" name="Rectangle 13"/>
           <p:cNvSpPr/>
           <p:nvPr/>
         </p:nvSpPr>
         <p:spPr>
           <a:xfrm>
-            <a:off x="635000" y="4597400"/>
-            <a:ext cx="3810000" cy="1371600"/>
+            <a:off x="635000" y="4978400"/>
+            <a:ext cx="3810000" cy="1016000"/>
           </a:xfrm>
           <a:prstGeom prst="rect">
             <a:avLst/>
@@ -7980,14 +8068,14 @@
       </p:sp>
       <p:sp>
         <p:nvSpPr>
-          <p:cNvPr id="13" name="TextBox 12"/>
-          <p:cNvSpPr txBox="1"/>
-          <p:nvPr/>
-        </p:nvSpPr>
-        <p:spPr>
-          <a:xfrm>
-            <a:off x="787400" y="4699000"/>
-            <a:ext cx="3556000" cy="1219200"/>
+          <p:cNvPr id="15" name="TextBox 14"/>
+          <p:cNvSpPr txBox="1"/>
+          <p:nvPr/>
+        </p:nvSpPr>
+        <p:spPr>
+          <a:xfrm>
+            <a:off x="787400" y="5054600"/>
+            <a:ext cx="3556000" cy="889000"/>
           </a:xfrm>
           <a:prstGeom prst="rect">
             <a:avLst/>
@@ -8012,7 +8100,7 @@
                 </a:solidFill>
                 <a:latin typeface="Arial"/>
               </a:rPr>
-              <a:t>Merge check</a:t>
+              <a:t>Merged on 28 October</a:t>
             </a:r>
           </a:p>
           <a:p>
@@ -8028,14 +8116,14 @@
                 </a:solidFill>
                 <a:latin typeface="Arial"/>
               </a:rPr>
-              <a:t>No conflicts with today's main; 108 tests and Ruff pass after the merge</a:t>
-            </a:r>
-          </a:p>
-        </p:txBody>
-      </p:sp>
-      <p:sp>
-        <p:nvSpPr>
-          <p:cNvPr id="14" name="TextBox 13"/>
+              <a:t>pull request #1; 108 tests and Ruff pass on main</a:t>
+            </a:r>
+          </a:p>
+        </p:txBody>
+      </p:sp>
+      <p:sp>
+        <p:nvSpPr>
+          <p:cNvPr id="16" name="TextBox 15"/>
           <p:cNvSpPr txBox="1"/>
           <p:nvPr/>
         </p:nvSpPr>
@@ -8063,14 +8151,14 @@
                 </a:solidFill>
                 <a:latin typeface="Arial"/>
               </a:rPr>
-              <a:t>STILL OPEN · BEFORE MERGE</a:t>
-            </a:r>
-          </a:p>
-        </p:txBody>
-      </p:sp>
-      <p:sp>
-        <p:nvSpPr>
-          <p:cNvPr id="15" name="Oval 14"/>
+              <a:t>STILL OPEN · NEXT WEEK</a:t>
+            </a:r>
+          </a:p>
+        </p:txBody>
+      </p:sp>
+      <p:sp>
+        <p:nvSpPr>
+          <p:cNvPr id="17" name="Oval 16"/>
           <p:cNvSpPr/>
           <p:nvPr/>
         </p:nvSpPr>
@@ -8123,7 +8211,7 @@
       </p:sp>
       <p:sp>
         <p:nvSpPr>
-          <p:cNvPr id="16" name="TextBox 15"/>
+          <p:cNvPr id="18" name="TextBox 17"/>
           <p:cNvSpPr txBox="1"/>
           <p:nvPr/>
         </p:nvSpPr>
@@ -8170,13 +8258,13 @@
       </p:sp>
       <p:sp>
         <p:nvSpPr>
-          <p:cNvPr id="17" name="Oval 16"/>
+          <p:cNvPr id="19" name="Oval 18"/>
           <p:cNvSpPr/>
           <p:nvPr/>
         </p:nvSpPr>
         <p:spPr>
           <a:xfrm>
-            <a:off x="4826000" y="2908300"/>
+            <a:off x="4826000" y="3009900"/>
             <a:ext cx="279400" cy="279400"/>
           </a:xfrm>
           <a:prstGeom prst="ellipse">
@@ -8223,13 +8311,13 @@
       </p:sp>
       <p:sp>
         <p:nvSpPr>
-          <p:cNvPr id="18" name="TextBox 17"/>
-          <p:cNvSpPr txBox="1"/>
-          <p:nvPr/>
-        </p:nvSpPr>
-        <p:spPr>
-          <a:xfrm>
-            <a:off x="5207000" y="2870200"/>
+          <p:cNvPr id="20" name="TextBox 19"/>
+          <p:cNvSpPr txBox="1"/>
+          <p:nvPr/>
+        </p:nvSpPr>
+        <p:spPr>
+          <a:xfrm>
+            <a:off x="5207000" y="2971800"/>
             <a:ext cx="6362700" cy="635000"/>
           </a:xfrm>
           <a:prstGeom prst="rect">
@@ -8270,13 +8358,13 @@
       </p:sp>
       <p:sp>
         <p:nvSpPr>
-          <p:cNvPr id="19" name="Oval 18"/>
+          <p:cNvPr id="21" name="Oval 20"/>
           <p:cNvSpPr/>
           <p:nvPr/>
         </p:nvSpPr>
         <p:spPr>
           <a:xfrm>
-            <a:off x="4826000" y="3543300"/>
+            <a:off x="4826000" y="3746500"/>
             <a:ext cx="279400" cy="279400"/>
           </a:xfrm>
           <a:prstGeom prst="ellipse">
@@ -8323,13 +8411,13 @@
       </p:sp>
       <p:sp>
         <p:nvSpPr>
-          <p:cNvPr id="20" name="TextBox 19"/>
-          <p:cNvSpPr txBox="1"/>
-          <p:nvPr/>
-        </p:nvSpPr>
-        <p:spPr>
-          <a:xfrm>
-            <a:off x="5207000" y="3505200"/>
+          <p:cNvPr id="22" name="TextBox 21"/>
+          <p:cNvSpPr txBox="1"/>
+          <p:nvPr/>
+        </p:nvSpPr>
+        <p:spPr>
+          <a:xfrm>
+            <a:off x="5207000" y="3708400"/>
             <a:ext cx="6362700" cy="635000"/>
           </a:xfrm>
           <a:prstGeom prst="rect">
@@ -8351,7 +8439,7 @@
                 </a:solidFill>
                 <a:latin typeface="Arial"/>
               </a:rPr>
-              <a:t>DATABASE.md says "planned"</a:t>
+              <a:t>Exact, case-sensitive match</a:t>
             </a:r>
           </a:p>
           <a:p>
@@ -8363,20 +8451,20 @@
                 </a:solidFill>
                 <a:latin typeface="Arial"/>
               </a:rPr>
-              <a:t>retrieval is implemented now</a:t>
-            </a:r>
-          </a:p>
-        </p:txBody>
-      </p:sp>
-      <p:sp>
-        <p:nvSpPr>
-          <p:cNvPr id="21" name="Oval 20"/>
+              <a:t>"Water" ≠ "water"; photo requests never reused</a:t>
+            </a:r>
+          </a:p>
+        </p:txBody>
+      </p:sp>
+      <p:sp>
+        <p:nvSpPr>
+          <p:cNvPr id="23" name="Oval 22"/>
           <p:cNvSpPr/>
           <p:nvPr/>
         </p:nvSpPr>
         <p:spPr>
           <a:xfrm>
-            <a:off x="4826000" y="4178300"/>
+            <a:off x="4826000" y="4483100"/>
             <a:ext cx="279400" cy="279400"/>
           </a:xfrm>
           <a:prstGeom prst="ellipse">
@@ -8423,13 +8511,13 @@
       </p:sp>
       <p:sp>
         <p:nvSpPr>
-          <p:cNvPr id="22" name="TextBox 21"/>
-          <p:cNvSpPr txBox="1"/>
-          <p:nvPr/>
-        </p:nvSpPr>
-        <p:spPr>
-          <a:xfrm>
-            <a:off x="5207000" y="4140200"/>
+          <p:cNvPr id="24" name="TextBox 23"/>
+          <p:cNvSpPr txBox="1"/>
+          <p:nvPr/>
+        </p:nvSpPr>
+        <p:spPr>
+          <a:xfrm>
+            <a:off x="5207000" y="4445000"/>
             <a:ext cx="6362700" cy="635000"/>
           </a:xfrm>
           <a:prstGeom prst="rect">
@@ -8451,7 +8539,7 @@
                 </a:solidFill>
                 <a:latin typeface="Arial"/>
               </a:rPr>
-              <a:t>Exact, case-sensitive match</a:t>
+              <a:t>Reused sentence cannot be accepted</a:t>
             </a:r>
           </a:p>
           <a:p>
@@ -8463,20 +8551,20 @@
                 </a:solidFill>
                 <a:latin typeface="Arial"/>
               </a:rPr>
-              <a:t>"Water" ≠ "water"; photo requests never reused</a:t>
-            </a:r>
-          </a:p>
-        </p:txBody>
-      </p:sp>
-      <p:sp>
-        <p:nvSpPr>
-          <p:cNvPr id="23" name="Oval 22"/>
+              <a:t>agree how a new interaction is recorded; no user scope yet</a:t>
+            </a:r>
+          </a:p>
+        </p:txBody>
+      </p:sp>
+      <p:sp>
+        <p:nvSpPr>
+          <p:cNvPr id="25" name="Oval 24"/>
           <p:cNvSpPr/>
           <p:nvPr/>
         </p:nvSpPr>
         <p:spPr>
           <a:xfrm>
-            <a:off x="4826000" y="4813300"/>
+            <a:off x="4826000" y="5219700"/>
             <a:ext cx="279400" cy="279400"/>
           </a:xfrm>
           <a:prstGeom prst="ellipse">
@@ -8523,113 +8611,13 @@
       </p:sp>
       <p:sp>
         <p:nvSpPr>
-          <p:cNvPr id="24" name="TextBox 23"/>
-          <p:cNvSpPr txBox="1"/>
-          <p:nvPr/>
-        </p:nvSpPr>
-        <p:spPr>
-          <a:xfrm>
-            <a:off x="5207000" y="4775200"/>
-            <a:ext cx="6362700" cy="635000"/>
-          </a:xfrm>
-          <a:prstGeom prst="rect">
-            <a:avLst/>
-          </a:prstGeom>
-          <a:noFill/>
-        </p:spPr>
-        <p:txBody>
-          <a:bodyPr wrap="square" lIns="45720" rIns="45720" tIns="12700" bIns="12700" anchor="t">
-            <a:spAutoFit/>
-          </a:bodyPr>
-          <a:lstStyle/>
-          <a:p>
-            <a:pPr algn="l"/>
-            <a:r>
-              <a:rPr sz="1500" b="1" i="0">
-                <a:solidFill>
-                  <a:srgbClr val="13263A"/>
-                </a:solidFill>
-                <a:latin typeface="Arial"/>
-              </a:rPr>
-              <a:t>Reused sentence cannot be accepted</a:t>
-            </a:r>
-          </a:p>
-          <a:p>
-            <a:pPr algn="l"/>
-            <a:r>
-              <a:rPr sz="1350" b="0" i="0">
-                <a:solidFill>
-                  <a:srgbClr val="647080"/>
-                </a:solidFill>
-                <a:latin typeface="Arial"/>
-              </a:rPr>
-              <a:t>agree how a new interaction is recorded; no user scope yet</a:t>
-            </a:r>
-          </a:p>
-        </p:txBody>
-      </p:sp>
-      <p:sp>
-        <p:nvSpPr>
-          <p:cNvPr id="25" name="Oval 24"/>
-          <p:cNvSpPr/>
-          <p:nvPr/>
-        </p:nvSpPr>
-        <p:spPr>
-          <a:xfrm>
-            <a:off x="4826000" y="5448300"/>
-            <a:ext cx="279400" cy="279400"/>
-          </a:xfrm>
-          <a:prstGeom prst="ellipse">
-            <a:avLst/>
-          </a:prstGeom>
-          <a:solidFill>
-            <a:srgbClr val="255CF0"/>
-          </a:solidFill>
-          <a:ln>
-            <a:noFill/>
-          </a:ln>
-          <a:effectLst/>
-        </p:spPr>
-        <p:style>
-          <a:lnRef idx="1">
-            <a:schemeClr val="accent1"/>
-          </a:lnRef>
-          <a:fillRef idx="3">
-            <a:schemeClr val="accent1"/>
-          </a:fillRef>
-          <a:effectRef idx="2">
-            <a:schemeClr val="accent1"/>
-          </a:effectRef>
-          <a:fontRef idx="minor">
-            <a:schemeClr val="lt1"/>
-          </a:fontRef>
-        </p:style>
-        <p:txBody>
-          <a:bodyPr rtlCol="0" anchor="ctr" lIns="0" rIns="0" tIns="0" bIns="0"/>
-          <a:lstStyle/>
-          <a:p>
-            <a:pPr algn="ctr"/>
-            <a:r>
-              <a:rPr sz="1200" b="1">
-                <a:solidFill>
-                  <a:srgbClr val="FFFFFF"/>
-                </a:solidFill>
-                <a:latin typeface="Arial"/>
-              </a:rPr>
-              <a:t>6</a:t>
-            </a:r>
-          </a:p>
-        </p:txBody>
-      </p:sp>
-      <p:sp>
-        <p:nvSpPr>
           <p:cNvPr id="26" name="TextBox 25"/>
           <p:cNvSpPr txBox="1"/>
           <p:nvPr/>
         </p:nvSpPr>
         <p:spPr>
           <a:xfrm>
-            <a:off x="5207000" y="5410200"/>
+            <a:off x="5207000" y="5181600"/>
             <a:ext cx="6362700" cy="635000"/>
           </a:xfrm>
           <a:prstGeom prst="rect">
@@ -22692,7 +22680,7 @@
                           </a:solidFill>
                           <a:latin typeface="Arial"/>
                         </a:rPr>
-                        <a:t>no free quota</a:t>
+                        <a:t>no free quota (inferred)</a:t>
                       </a:r>
                     </a:p>
                   </a:txBody>
@@ -22971,29 +22959,104 @@
         </p:nvSpPr>
         <p:spPr>
           <a:xfrm>
-            <a:off x="635000" y="5740400"/>
-            <a:ext cx="10668000" cy="457200"/>
-          </a:xfrm>
-          <a:prstGeom prst="rect">
-            <a:avLst/>
-          </a:prstGeom>
-          <a:noFill/>
-        </p:spPr>
-        <p:txBody>
-          <a:bodyPr wrap="square" lIns="45720" rIns="45720" tIns="12700" bIns="12700" anchor="t">
-            <a:spAutoFit/>
-          </a:bodyPr>
-          <a:lstStyle/>
-          <a:p>
-            <a:pPr algn="l"/>
-            <a:r>
-              <a:rPr sz="1350" b="0" i="0">
+            <a:off x="635000" y="5689600"/>
+            <a:ext cx="10934700" cy="508000"/>
+          </a:xfrm>
+          <a:prstGeom prst="rect">
+            <a:avLst/>
+          </a:prstGeom>
+          <a:noFill/>
+        </p:spPr>
+        <p:txBody>
+          <a:bodyPr wrap="square" lIns="45720" rIns="45720" tIns="12700" bIns="12700" anchor="t">
+            <a:spAutoFit/>
+          </a:bodyPr>
+          <a:lstStyle/>
+          <a:p>
+            <a:pPr algn="l"/>
+            <a:r>
+              <a:rPr sz="1250" b="1" i="0">
                 <a:solidFill>
                   <a:srgbClr val="647080"/>
                 </a:solidFill>
                 <a:latin typeface="Arial"/>
               </a:rPr>
-              <a:t>Highlighted: usable in the chain. Limits are read from the quota names in Google's 429 answers. Tool: src/ai/gemini_rate_limit.py survey</a:t>
+              <a:t>429 </a:t>
+            </a:r>
+            <a:r>
+              <a:rPr sz="1250" b="0" i="0">
+                <a:solidFill>
+                  <a:srgbClr val="647080"/>
+                </a:solidFill>
+                <a:latin typeface="Arial"/>
+              </a:rPr>
+              <a:t>quota used up · </a:t>
+            </a:r>
+            <a:r>
+              <a:rPr sz="1250" b="1" i="0">
+                <a:solidFill>
+                  <a:srgbClr val="647080"/>
+                </a:solidFill>
+                <a:latin typeface="Arial"/>
+              </a:rPr>
+              <a:t>503 </a:t>
+            </a:r>
+            <a:r>
+              <a:rPr sz="1250" b="0" i="0">
+                <a:solidFill>
+                  <a:srgbClr val="647080"/>
+                </a:solidFill>
+                <a:latin typeface="Arial"/>
+              </a:rPr>
+              <a:t>Google overloaded, try later · </a:t>
+            </a:r>
+            <a:r>
+              <a:rPr sz="1250" b="1" i="0">
+                <a:solidFill>
+                  <a:srgbClr val="647080"/>
+                </a:solidFill>
+                <a:latin typeface="Arial"/>
+              </a:rPr>
+              <a:t>404 </a:t>
+            </a:r>
+            <a:r>
+              <a:rPr sz="1250" b="0" i="0">
+                <a:solidFill>
+                  <a:srgbClr val="647080"/>
+                </a:solidFill>
+                <a:latin typeface="Arial"/>
+              </a:rPr>
+              <a:t>model closed to new keys · </a:t>
+            </a:r>
+            <a:r>
+              <a:rPr sz="1250" b="1" i="0">
+                <a:solidFill>
+                  <a:srgbClr val="647080"/>
+                </a:solidFill>
+                <a:latin typeface="Arial"/>
+              </a:rPr>
+              <a:t>500 </a:t>
+            </a:r>
+            <a:r>
+              <a:rPr sz="1250" b="0" i="0">
+                <a:solidFill>
+                  <a:srgbClr val="647080"/>
+                </a:solidFill>
+                <a:latin typeface="Arial"/>
+              </a:rPr>
+              <a:t>server error</a:t>
+            </a:r>
+          </a:p>
+          <a:p>
+            <a:pPr algn="l"/>
+            <a:r>
+              <a:rPr sz="1250" b="0" i="0">
+                <a:solidFill>
+                  <a:srgbClr val="647080"/>
+                </a:solidFill>
+                <a:latin typeface="Arial"/>
+              </a:rPr>
+              <a:t>Highlighted: usable in the chain. Limits are the values in Google's 429 answers.</a:t>
             </a:r>
           </a:p>
         </p:txBody>
@@ -23240,7 +23303,7 @@
                 </a:solidFill>
                 <a:latin typeface="Arial"/>
               </a:rPr>
-              <a:t>Flash-Lite models: no 429 in a 15-call burst</a:t>
+              <a:t>3.5 Flash-Lite: 15 calls in 15 s, no 429 (3.1: ≥11/min)</a:t>
             </a:r>
           </a:p>
         </p:txBody>
@@ -23586,7 +23649,7 @@
                 </a:solidFill>
                 <a:latin typeface="Arial"/>
               </a:rPr>
-              <a:t>free calls on Pro, Omni and gemini-4-argon</a:t>
+              <a:t>free calls on Pro, Omni, gemini-4-argon (inferred)</a:t>
             </a:r>
           </a:p>
         </p:txBody>
@@ -26431,7 +26494,7 @@
                           </a:solidFill>
                           <a:latin typeface="Arial"/>
                         </a:rPr>
-                        <a:t>SRS v0.3.1</a:t>
+                        <a:t>Final SRS in Markdown</a:t>
                       </a:r>
                     </a:p>
                   </a:txBody>
@@ -26477,7 +26540,7 @@
                           </a:solidFill>
                           <a:latin typeface="Arial"/>
                         </a:rPr>
-                        <a:t>Abid</a:t>
+                        <a:t>Abid, Jiahui</a:t>
                       </a:r>
                     </a:p>
                   </a:txBody>
@@ -26523,7 +26586,7 @@
                           </a:solidFill>
                           <a:latin typeface="Arial"/>
                         </a:rPr>
-                        <a:t>Apply the review comments and restore the exact limits of v0.2</a:t>
+                        <a:t>Review comments, Mermaid diagrams, AI part corrected; PDF export</a:t>
                       </a:r>
                     </a:p>
                   </a:txBody>
@@ -26571,7 +26634,7 @@
                           </a:solidFill>
                           <a:latin typeface="Arial"/>
                         </a:rPr>
-                        <a:t>Merge the backend refactor</a:t>
+                        <a:t>Fix the open backend points</a:t>
                       </a:r>
                     </a:p>
                   </a:txBody>
@@ -26663,7 +26726,7 @@
                           </a:solidFill>
                           <a:latin typeface="Arial"/>
                         </a:rPr>
-                        <a:t>Fix the review findings, merge to main, similarity in the reuse service</a:t>
+                        <a:t>Close the session before the AI call, reuse in API.md, similarity matching</a:t>
                       </a:r>
                     </a:p>
                   </a:txBody>
@@ -26943,7 +27006,7 @@
                           </a:solidFill>
                           <a:latin typeface="Arial"/>
                         </a:rPr>
-                        <a:t>SentenceProvider with the backup chain, after the merge</a:t>
+                        <a:t>SentenceProvider with the backup chain, now that the refactor is merged</a:t>
                       </a:r>
                     </a:p>
                   </a:txBody>
@@ -27338,7 +27401,7 @@
                 </a:solidFill>
                 <a:latin typeface="Arial"/>
               </a:rPr>
-              <a:t>Why the merge matters: </a:t>
+              <a:t>Unblocked: </a:t>
             </a:r>
             <a:r>
               <a:rPr sz="1400" b="0" i="0">
@@ -27347,7 +27410,7 @@
                 </a:solidFill>
                 <a:latin typeface="Arial"/>
               </a:rPr>
-              <a:t>the AI chain and the frontend both need the new backend structure</a:t>
+              <a:t>the backend refactor is on main, so the AI chain and the frontend can connect to it now</a:t>
             </a:r>
           </a:p>
         </p:txBody>

</xml_diff>